<commit_message>
Remove prazos e datas limite das ações do PGR
</commit_message>
<xml_diff>
--- a/Modelo_Devolutiva_SST_Fortneer.pptx
+++ b/Modelo_Devolutiva_SST_Fortneer.pptx
@@ -5135,19 +5135,7 @@
           <a:bodyPr xmlns:a="http://schemas.openxmlformats.org/drawingml/2006/main" anchor="ctr"/>
           <a:lstStyle xmlns:a="http://schemas.openxmlformats.org/drawingml/2006/main"/>
           <a:p xmlns:a="http://schemas.openxmlformats.org/drawingml/2006/main">
-            <a:pPr algn="ctr">
-              <a:defRPr sz="975" b="1">
-                <a:solidFill>
-                  <a:srgbClr val="FFFFFF"/>
-                </a:solidFill>
-              </a:defRPr>
-            </a:pPr>
-            <a:r>
-              <a:rPr sz="975" b="1">
-                <a:solidFill>
-                  <a:srgbClr val="FFFFFF"/>
-                </a:solidFill>
-              </a:rPr>
+            <a:r>
               <a:t>NÍVEL</a:t>
             </a:r>
           </a:p>
@@ -5218,19 +5206,7 @@
           <a:bodyPr xmlns:a="http://schemas.openxmlformats.org/drawingml/2006/main" anchor="ctr"/>
           <a:lstStyle xmlns:a="http://schemas.openxmlformats.org/drawingml/2006/main"/>
           <a:p xmlns:a="http://schemas.openxmlformats.org/drawingml/2006/main">
-            <a:pPr algn="ctr">
-              <a:defRPr sz="975" b="1">
-                <a:solidFill>
-                  <a:srgbClr val="FFFFFF"/>
-                </a:solidFill>
-              </a:defRPr>
-            </a:pPr>
-            <a:r>
-              <a:rPr sz="975" b="1">
-                <a:solidFill>
-                  <a:srgbClr val="FFFFFF"/>
-                </a:solidFill>
-              </a:rPr>
+            <a:r>
               <a:t>AÇÃO RECOMENDADA</a:t>
             </a:r>
           </a:p>
@@ -5301,19 +5277,7 @@
           <a:bodyPr xmlns:a="http://schemas.openxmlformats.org/drawingml/2006/main" anchor="ctr"/>
           <a:lstStyle xmlns:a="http://schemas.openxmlformats.org/drawingml/2006/main"/>
           <a:p xmlns:a="http://schemas.openxmlformats.org/drawingml/2006/main">
-            <a:pPr algn="ctr">
-              <a:defRPr sz="975" b="1">
-                <a:solidFill>
-                  <a:srgbClr val="FFFFFF"/>
-                </a:solidFill>
-              </a:defRPr>
-            </a:pPr>
-            <a:r>
-              <a:rPr sz="975" b="1">
-                <a:solidFill>
-                  <a:srgbClr val="FFFFFF"/>
-                </a:solidFill>
-              </a:rPr>
+            <a:r>
               <a:t>RESPONSÁVEL</a:t>
             </a:r>
           </a:p>
@@ -5384,20 +5348,8 @@
           <a:bodyPr xmlns:a="http://schemas.openxmlformats.org/drawingml/2006/main" anchor="ctr"/>
           <a:lstStyle xmlns:a="http://schemas.openxmlformats.org/drawingml/2006/main"/>
           <a:p xmlns:a="http://schemas.openxmlformats.org/drawingml/2006/main">
-            <a:pPr algn="ctr">
-              <a:defRPr sz="975" b="1">
-                <a:solidFill>
-                  <a:srgbClr val="FFFFFF"/>
-                </a:solidFill>
-              </a:defRPr>
-            </a:pPr>
-            <a:r>
-              <a:rPr sz="975" b="1">
-                <a:solidFill>
-                  <a:srgbClr val="FFFFFF"/>
-                </a:solidFill>
-              </a:rPr>
-              <a:t>PRAZO</a:t>
+            <a:r>
+              <a:t>EVIDÊNCIA</a:t>
             </a:r>
           </a:p>
         </p:txBody>
@@ -5467,19 +5419,7 @@
           <a:bodyPr xmlns:a="http://schemas.openxmlformats.org/drawingml/2006/main" anchor="ctr"/>
           <a:lstStyle xmlns:a="http://schemas.openxmlformats.org/drawingml/2006/main"/>
           <a:p xmlns:a="http://schemas.openxmlformats.org/drawingml/2006/main">
-            <a:pPr algn="ctr">
-              <a:defRPr sz="975" b="1">
-                <a:solidFill>
-                  <a:srgbClr val="FFFFFF"/>
-                </a:solidFill>
-              </a:defRPr>
-            </a:pPr>
-            <a:r>
-              <a:rPr sz="975" b="1">
-                <a:solidFill>
-                  <a:srgbClr val="FFFFFF"/>
-                </a:solidFill>
-              </a:rPr>
+            <a:r>
               <a:t>STATUS</a:t>
             </a:r>
           </a:p>
@@ -5805,20 +5745,8 @@
           <a:bodyPr xmlns:a="http://schemas.openxmlformats.org/drawingml/2006/main" anchor="ctr"/>
           <a:lstStyle xmlns:a="http://schemas.openxmlformats.org/drawingml/2006/main"/>
           <a:p xmlns:a="http://schemas.openxmlformats.org/drawingml/2006/main">
-            <a:pPr algn="ctr">
-              <a:defRPr sz="1050" b="0">
-                <a:solidFill>
-                  <a:srgbClr val="60776B"/>
-                </a:solidFill>
-              </a:defRPr>
-            </a:pPr>
-            <a:r>
-              <a:rPr sz="1050" b="0">
-                <a:solidFill>
-                  <a:srgbClr val="60776B"/>
-                </a:solidFill>
-              </a:rPr>
-              <a:t>[dd/mm]</a:t>
+            <a:r>
+              <a:t>[Evidência]</a:t>
             </a:r>
           </a:p>
         </p:txBody>
@@ -6228,20 +6156,8 @@
           <a:bodyPr xmlns:a="http://schemas.openxmlformats.org/drawingml/2006/main" anchor="ctr"/>
           <a:lstStyle xmlns:a="http://schemas.openxmlformats.org/drawingml/2006/main"/>
           <a:p xmlns:a="http://schemas.openxmlformats.org/drawingml/2006/main">
-            <a:pPr algn="ctr">
-              <a:defRPr sz="1050" b="0">
-                <a:solidFill>
-                  <a:srgbClr val="60776B"/>
-                </a:solidFill>
-              </a:defRPr>
-            </a:pPr>
-            <a:r>
-              <a:rPr sz="1050" b="0">
-                <a:solidFill>
-                  <a:srgbClr val="60776B"/>
-                </a:solidFill>
-              </a:rPr>
-              <a:t>[dd/mm]</a:t>
+            <a:r>
+              <a:t>[Evidência]</a:t>
             </a:r>
           </a:p>
         </p:txBody>
@@ -6651,20 +6567,8 @@
           <a:bodyPr xmlns:a="http://schemas.openxmlformats.org/drawingml/2006/main" anchor="ctr"/>
           <a:lstStyle xmlns:a="http://schemas.openxmlformats.org/drawingml/2006/main"/>
           <a:p xmlns:a="http://schemas.openxmlformats.org/drawingml/2006/main">
-            <a:pPr algn="ctr">
-              <a:defRPr sz="1050" b="0">
-                <a:solidFill>
-                  <a:srgbClr val="60776B"/>
-                </a:solidFill>
-              </a:defRPr>
-            </a:pPr>
-            <a:r>
-              <a:rPr sz="1050" b="0">
-                <a:solidFill>
-                  <a:srgbClr val="60776B"/>
-                </a:solidFill>
-              </a:rPr>
-              <a:t>[dd/mm]</a:t>
+            <a:r>
+              <a:t>[Evidência]</a:t>
             </a:r>
           </a:p>
         </p:txBody>
@@ -7074,20 +6978,8 @@
           <a:bodyPr xmlns:a="http://schemas.openxmlformats.org/drawingml/2006/main" anchor="ctr"/>
           <a:lstStyle xmlns:a="http://schemas.openxmlformats.org/drawingml/2006/main"/>
           <a:p xmlns:a="http://schemas.openxmlformats.org/drawingml/2006/main">
-            <a:pPr algn="ctr">
-              <a:defRPr sz="1050" b="0">
-                <a:solidFill>
-                  <a:srgbClr val="60776B"/>
-                </a:solidFill>
-              </a:defRPr>
-            </a:pPr>
-            <a:r>
-              <a:rPr sz="1050" b="0">
-                <a:solidFill>
-                  <a:srgbClr val="60776B"/>
-                </a:solidFill>
-              </a:rPr>
-              <a:t>[dd/mm]</a:t>
+            <a:r>
+              <a:t>[Evidência]</a:t>
             </a:r>
           </a:p>
         </p:txBody>
@@ -7497,20 +7389,8 @@
           <a:bodyPr xmlns:a="http://schemas.openxmlformats.org/drawingml/2006/main" anchor="ctr"/>
           <a:lstStyle xmlns:a="http://schemas.openxmlformats.org/drawingml/2006/main"/>
           <a:p xmlns:a="http://schemas.openxmlformats.org/drawingml/2006/main">
-            <a:pPr algn="ctr">
-              <a:defRPr sz="1050" b="0">
-                <a:solidFill>
-                  <a:srgbClr val="60776B"/>
-                </a:solidFill>
-              </a:defRPr>
-            </a:pPr>
-            <a:r>
-              <a:rPr sz="1050" b="0">
-                <a:solidFill>
-                  <a:srgbClr val="60776B"/>
-                </a:solidFill>
-              </a:rPr>
-              <a:t>[dd/mm]</a:t>
+            <a:r>
+              <a:t>[Evidência]</a:t>
             </a:r>
           </a:p>
         </p:txBody>
@@ -7794,20 +7674,8 @@
           <a:bodyPr xmlns:a="http://schemas.openxmlformats.org/drawingml/2006/main" anchor="ctr"/>
           <a:lstStyle xmlns:a="http://schemas.openxmlformats.org/drawingml/2006/main"/>
           <a:p xmlns:a="http://schemas.openxmlformats.org/drawingml/2006/main">
-            <a:pPr algn="l">
-              <a:defRPr sz="2475" b="1">
-                <a:solidFill>
-                  <a:srgbClr val="074B32"/>
-                </a:solidFill>
-              </a:defRPr>
-            </a:pPr>
-            <a:r>
-              <a:rPr sz="2475" b="1">
-                <a:solidFill>
-                  <a:srgbClr val="074B32"/>
-                </a:solidFill>
-              </a:rPr>
-              <a:t>O cronograma transforma recomendações em rotina</a:t>
+            <a:r>
+              <a:t>Acompanhamento das medidas por prioridade</a:t>
             </a:r>
           </a:p>
         </p:txBody>
@@ -8095,20 +7963,8 @@
           <a:bodyPr xmlns:a="http://schemas.openxmlformats.org/drawingml/2006/main" anchor="ctr"/>
           <a:lstStyle xmlns:a="http://schemas.openxmlformats.org/drawingml/2006/main"/>
           <a:p xmlns:a="http://schemas.openxmlformats.org/drawingml/2006/main">
-            <a:pPr algn="ctr">
-              <a:defRPr sz="1350" b="1">
-                <a:solidFill>
-                  <a:srgbClr val="DDF3E5"/>
-                </a:solidFill>
-              </a:defRPr>
-            </a:pPr>
-            <a:r>
-              <a:rPr sz="1350" b="1">
-                <a:solidFill>
-                  <a:srgbClr val="DDF3E5"/>
-                </a:solidFill>
-              </a:rPr>
-              <a:t>0–30 DIAS</a:t>
+            <a:r>
+              <a:t>PRIORIDADE ALTA</a:t>
             </a:r>
           </a:p>
         </p:txBody>
@@ -8145,64 +8001,20 @@
           <a:bodyPr xmlns:a="http://schemas.openxmlformats.org/drawingml/2006/main" anchor="ctr"/>
           <a:lstStyle xmlns:a="http://schemas.openxmlformats.org/drawingml/2006/main"/>
           <a:p xmlns:a="http://schemas.openxmlformats.org/drawingml/2006/main">
-            <a:pPr algn="ctr">
-              <a:defRPr sz="1350" b="0">
-                <a:solidFill>
-                  <a:srgbClr val="FFFFFF"/>
-                </a:solidFill>
-              </a:defRPr>
-            </a:pPr>
-            <a:r>
-              <a:rPr sz="1350" b="0">
-                <a:solidFill>
-                  <a:srgbClr val="FFFFFF"/>
-                </a:solidFill>
-              </a:rPr>
-              <a:t>[Ação 1]</a:t>
-            </a:r>
-          </a:p>
-          <a:p xmlns:a="http://schemas.openxmlformats.org/drawingml/2006/main">
-            <a:r>
-              <a:t/>
-            </a:r>
-          </a:p>
-          <a:p xmlns:a="http://schemas.openxmlformats.org/drawingml/2006/main">
-            <a:pPr algn="ctr">
-              <a:defRPr sz="1350" b="0">
-                <a:solidFill>
-                  <a:srgbClr val="FFFFFF"/>
-                </a:solidFill>
-              </a:defRPr>
-            </a:pPr>
-            <a:r>
-              <a:rPr sz="1350" b="0">
-                <a:solidFill>
-                  <a:srgbClr val="FFFFFF"/>
-                </a:solidFill>
-              </a:rPr>
-              <a:t>[Ação 2]</a:t>
-            </a:r>
-          </a:p>
-          <a:p xmlns:a="http://schemas.openxmlformats.org/drawingml/2006/main">
-            <a:r>
-              <a:t/>
-            </a:r>
-          </a:p>
-          <a:p xmlns:a="http://schemas.openxmlformats.org/drawingml/2006/main">
-            <a:pPr algn="ctr">
-              <a:defRPr sz="1350" b="0">
-                <a:solidFill>
-                  <a:srgbClr val="FFFFFF"/>
-                </a:solidFill>
-              </a:defRPr>
-            </a:pPr>
-            <a:r>
-              <a:rPr sz="1350" b="0">
-                <a:solidFill>
-                  <a:srgbClr val="FFFFFF"/>
-                </a:solidFill>
-              </a:rPr>
-              <a:t>[Evidência esperada]</a:t>
+            <a:r>
+              <a:t>[Medidas]</a:t>
+            </a:r>
+          </a:p>
+          <a:p xmlns:a="http://schemas.openxmlformats.org/drawingml/2006/main"/>
+          <a:p xmlns:a="http://schemas.openxmlformats.org/drawingml/2006/main">
+            <a:r>
+              <a:t>[Status]</a:t>
+            </a:r>
+          </a:p>
+          <a:p xmlns:a="http://schemas.openxmlformats.org/drawingml/2006/main"/>
+          <a:p xmlns:a="http://schemas.openxmlformats.org/drawingml/2006/main">
+            <a:r>
+              <a:t>[Evidências]</a:t>
             </a:r>
           </a:p>
         </p:txBody>
@@ -8274,20 +8086,8 @@
           <a:bodyPr xmlns:a="http://schemas.openxmlformats.org/drawingml/2006/main" anchor="ctr"/>
           <a:lstStyle xmlns:a="http://schemas.openxmlformats.org/drawingml/2006/main"/>
           <a:p xmlns:a="http://schemas.openxmlformats.org/drawingml/2006/main">
-            <a:pPr algn="ctr">
-              <a:defRPr sz="1350" b="1">
-                <a:solidFill>
-                  <a:srgbClr val="0B7A4B"/>
-                </a:solidFill>
-              </a:defRPr>
-            </a:pPr>
-            <a:r>
-              <a:rPr sz="1350" b="1">
-                <a:solidFill>
-                  <a:srgbClr val="0B7A4B"/>
-                </a:solidFill>
-              </a:rPr>
-              <a:t>31–60 DIAS</a:t>
+            <a:r>
+              <a:t>PRIORIDADE MÉDIA</a:t>
             </a:r>
           </a:p>
         </p:txBody>
@@ -8324,64 +8124,20 @@
           <a:bodyPr xmlns:a="http://schemas.openxmlformats.org/drawingml/2006/main" anchor="ctr"/>
           <a:lstStyle xmlns:a="http://schemas.openxmlformats.org/drawingml/2006/main"/>
           <a:p xmlns:a="http://schemas.openxmlformats.org/drawingml/2006/main">
-            <a:pPr algn="ctr">
-              <a:defRPr sz="1350" b="0">
-                <a:solidFill>
-                  <a:srgbClr val="16372A"/>
-                </a:solidFill>
-              </a:defRPr>
-            </a:pPr>
-            <a:r>
-              <a:rPr sz="1350" b="0">
-                <a:solidFill>
-                  <a:srgbClr val="16372A"/>
-                </a:solidFill>
-              </a:rPr>
-              <a:t>[Ação 3]</a:t>
-            </a:r>
-          </a:p>
-          <a:p xmlns:a="http://schemas.openxmlformats.org/drawingml/2006/main">
-            <a:r>
-              <a:t/>
-            </a:r>
-          </a:p>
-          <a:p xmlns:a="http://schemas.openxmlformats.org/drawingml/2006/main">
-            <a:pPr algn="ctr">
-              <a:defRPr sz="1350" b="0">
-                <a:solidFill>
-                  <a:srgbClr val="16372A"/>
-                </a:solidFill>
-              </a:defRPr>
-            </a:pPr>
-            <a:r>
-              <a:rPr sz="1350" b="0">
-                <a:solidFill>
-                  <a:srgbClr val="16372A"/>
-                </a:solidFill>
-              </a:rPr>
-              <a:t>[Ação 4]</a:t>
-            </a:r>
-          </a:p>
-          <a:p xmlns:a="http://schemas.openxmlformats.org/drawingml/2006/main">
-            <a:r>
-              <a:t/>
-            </a:r>
-          </a:p>
-          <a:p xmlns:a="http://schemas.openxmlformats.org/drawingml/2006/main">
-            <a:pPr algn="ctr">
-              <a:defRPr sz="1350" b="0">
-                <a:solidFill>
-                  <a:srgbClr val="16372A"/>
-                </a:solidFill>
-              </a:defRPr>
-            </a:pPr>
-            <a:r>
-              <a:rPr sz="1350" b="0">
-                <a:solidFill>
-                  <a:srgbClr val="16372A"/>
-                </a:solidFill>
-              </a:rPr>
-              <a:t>[Evidência esperada]</a:t>
+            <a:r>
+              <a:t>[Medidas]</a:t>
+            </a:r>
+          </a:p>
+          <a:p xmlns:a="http://schemas.openxmlformats.org/drawingml/2006/main"/>
+          <a:p xmlns:a="http://schemas.openxmlformats.org/drawingml/2006/main">
+            <a:r>
+              <a:t>[Status]</a:t>
+            </a:r>
+          </a:p>
+          <a:p xmlns:a="http://schemas.openxmlformats.org/drawingml/2006/main"/>
+          <a:p xmlns:a="http://schemas.openxmlformats.org/drawingml/2006/main">
+            <a:r>
+              <a:t>[Evidências]</a:t>
             </a:r>
           </a:p>
         </p:txBody>
@@ -8453,20 +8209,8 @@
           <a:bodyPr xmlns:a="http://schemas.openxmlformats.org/drawingml/2006/main" anchor="ctr"/>
           <a:lstStyle xmlns:a="http://schemas.openxmlformats.org/drawingml/2006/main"/>
           <a:p xmlns:a="http://schemas.openxmlformats.org/drawingml/2006/main">
-            <a:pPr algn="ctr">
-              <a:defRPr sz="1350" b="1">
-                <a:solidFill>
-                  <a:srgbClr val="0B7A4B"/>
-                </a:solidFill>
-              </a:defRPr>
-            </a:pPr>
-            <a:r>
-              <a:rPr sz="1350" b="1">
-                <a:solidFill>
-                  <a:srgbClr val="0B7A4B"/>
-                </a:solidFill>
-              </a:rPr>
-              <a:t>61–90 DIAS</a:t>
+            <a:r>
+              <a:t>PRIORIDADE BAIXA</a:t>
             </a:r>
           </a:p>
         </p:txBody>
@@ -8503,64 +8247,20 @@
           <a:bodyPr xmlns:a="http://schemas.openxmlformats.org/drawingml/2006/main" anchor="ctr"/>
           <a:lstStyle xmlns:a="http://schemas.openxmlformats.org/drawingml/2006/main"/>
           <a:p xmlns:a="http://schemas.openxmlformats.org/drawingml/2006/main">
-            <a:pPr algn="ctr">
-              <a:defRPr sz="1350" b="0">
-                <a:solidFill>
-                  <a:srgbClr val="16372A"/>
-                </a:solidFill>
-              </a:defRPr>
-            </a:pPr>
-            <a:r>
-              <a:rPr sz="1350" b="0">
-                <a:solidFill>
-                  <a:srgbClr val="16372A"/>
-                </a:solidFill>
-              </a:rPr>
-              <a:t>[Ação 5]</a:t>
-            </a:r>
-          </a:p>
-          <a:p xmlns:a="http://schemas.openxmlformats.org/drawingml/2006/main">
-            <a:r>
-              <a:t/>
-            </a:r>
-          </a:p>
-          <a:p xmlns:a="http://schemas.openxmlformats.org/drawingml/2006/main">
-            <a:pPr algn="ctr">
-              <a:defRPr sz="1350" b="0">
-                <a:solidFill>
-                  <a:srgbClr val="16372A"/>
-                </a:solidFill>
-              </a:defRPr>
-            </a:pPr>
-            <a:r>
-              <a:rPr sz="1350" b="0">
-                <a:solidFill>
-                  <a:srgbClr val="16372A"/>
-                </a:solidFill>
-              </a:rPr>
-              <a:t>[Ação 6]</a:t>
-            </a:r>
-          </a:p>
-          <a:p xmlns:a="http://schemas.openxmlformats.org/drawingml/2006/main">
-            <a:r>
-              <a:t/>
-            </a:r>
-          </a:p>
-          <a:p xmlns:a="http://schemas.openxmlformats.org/drawingml/2006/main">
-            <a:pPr algn="ctr">
-              <a:defRPr sz="1350" b="0">
-                <a:solidFill>
-                  <a:srgbClr val="16372A"/>
-                </a:solidFill>
-              </a:defRPr>
-            </a:pPr>
-            <a:r>
-              <a:rPr sz="1350" b="0">
-                <a:solidFill>
-                  <a:srgbClr val="16372A"/>
-                </a:solidFill>
-              </a:rPr>
-              <a:t>[Evidência esperada]</a:t>
+            <a:r>
+              <a:t>[Medidas]</a:t>
+            </a:r>
+          </a:p>
+          <a:p xmlns:a="http://schemas.openxmlformats.org/drawingml/2006/main"/>
+          <a:p xmlns:a="http://schemas.openxmlformats.org/drawingml/2006/main">
+            <a:r>
+              <a:t>[Status]</a:t>
+            </a:r>
+          </a:p>
+          <a:p xmlns:a="http://schemas.openxmlformats.org/drawingml/2006/main"/>
+          <a:p xmlns:a="http://schemas.openxmlformats.org/drawingml/2006/main">
+            <a:r>
+              <a:t>[Evidências]</a:t>
             </a:r>
           </a:p>
         </p:txBody>
@@ -8632,20 +8332,8 @@
           <a:bodyPr xmlns:a="http://schemas.openxmlformats.org/drawingml/2006/main" anchor="ctr"/>
           <a:lstStyle xmlns:a="http://schemas.openxmlformats.org/drawingml/2006/main"/>
           <a:p xmlns:a="http://schemas.openxmlformats.org/drawingml/2006/main">
-            <a:pPr algn="ctr">
-              <a:defRPr sz="1350" b="1">
-                <a:solidFill>
-                  <a:srgbClr val="0B7A4B"/>
-                </a:solidFill>
-              </a:defRPr>
-            </a:pPr>
-            <a:r>
-              <a:rPr sz="1350" b="1">
-                <a:solidFill>
-                  <a:srgbClr val="0B7A4B"/>
-                </a:solidFill>
-              </a:rPr>
-              <a:t>PRÓXIMO CICLO</a:t>
+            <a:r>
+              <a:t>CONCLUÍDAS</a:t>
             </a:r>
           </a:p>
         </p:txBody>
@@ -8682,64 +8370,20 @@
           <a:bodyPr xmlns:a="http://schemas.openxmlformats.org/drawingml/2006/main" anchor="ctr"/>
           <a:lstStyle xmlns:a="http://schemas.openxmlformats.org/drawingml/2006/main"/>
           <a:p xmlns:a="http://schemas.openxmlformats.org/drawingml/2006/main">
-            <a:pPr algn="ctr">
-              <a:defRPr sz="1350" b="0">
-                <a:solidFill>
-                  <a:srgbClr val="16372A"/>
-                </a:solidFill>
-              </a:defRPr>
-            </a:pPr>
-            <a:r>
-              <a:rPr sz="1350" b="0">
-                <a:solidFill>
-                  <a:srgbClr val="16372A"/>
-                </a:solidFill>
-              </a:rPr>
-              <a:t>[Ação 7]</a:t>
-            </a:r>
-          </a:p>
-          <a:p xmlns:a="http://schemas.openxmlformats.org/drawingml/2006/main">
-            <a:r>
-              <a:t/>
-            </a:r>
-          </a:p>
-          <a:p xmlns:a="http://schemas.openxmlformats.org/drawingml/2006/main">
-            <a:pPr algn="ctr">
-              <a:defRPr sz="1350" b="0">
-                <a:solidFill>
-                  <a:srgbClr val="16372A"/>
-                </a:solidFill>
-              </a:defRPr>
-            </a:pPr>
-            <a:r>
-              <a:rPr sz="1350" b="0">
-                <a:solidFill>
-                  <a:srgbClr val="16372A"/>
-                </a:solidFill>
-              </a:rPr>
-              <a:t>[Ação 8]</a:t>
-            </a:r>
-          </a:p>
-          <a:p xmlns:a="http://schemas.openxmlformats.org/drawingml/2006/main">
-            <a:r>
-              <a:t/>
-            </a:r>
-          </a:p>
-          <a:p xmlns:a="http://schemas.openxmlformats.org/drawingml/2006/main">
-            <a:pPr algn="ctr">
-              <a:defRPr sz="1350" b="0">
-                <a:solidFill>
-                  <a:srgbClr val="16372A"/>
-                </a:solidFill>
-              </a:defRPr>
-            </a:pPr>
-            <a:r>
-              <a:rPr sz="1350" b="0">
-                <a:solidFill>
-                  <a:srgbClr val="16372A"/>
-                </a:solidFill>
-              </a:rPr>
-              <a:t>[Evidência esperada]</a:t>
+            <a:r>
+              <a:t>[Medidas]</a:t>
+            </a:r>
+          </a:p>
+          <a:p xmlns:a="http://schemas.openxmlformats.org/drawingml/2006/main"/>
+          <a:p xmlns:a="http://schemas.openxmlformats.org/drawingml/2006/main">
+            <a:r>
+              <a:t>[Status]</a:t>
+            </a:r>
+          </a:p>
+          <a:p xmlns:a="http://schemas.openxmlformats.org/drawingml/2006/main"/>
+          <a:p xmlns:a="http://schemas.openxmlformats.org/drawingml/2006/main">
+            <a:r>
+              <a:t>[Evidências]</a:t>
             </a:r>
           </a:p>
         </p:txBody>
@@ -8809,20 +8453,8 @@
           <a:bodyPr xmlns:a="http://schemas.openxmlformats.org/drawingml/2006/main" anchor="ctr"/>
           <a:lstStyle xmlns:a="http://schemas.openxmlformats.org/drawingml/2006/main"/>
           <a:p xmlns:a="http://schemas.openxmlformats.org/drawingml/2006/main">
-            <a:pPr algn="ctr">
-              <a:defRPr sz="1275" b="1">
-                <a:solidFill>
-                  <a:srgbClr val="074B32"/>
-                </a:solidFill>
-              </a:defRPr>
-            </a:pPr>
-            <a:r>
-              <a:rPr sz="1275" b="1">
-                <a:solidFill>
-                  <a:srgbClr val="074B32"/>
-                </a:solidFill>
-              </a:rPr>
-              <a:t>Revisão de acompanhamento prevista para: [DATA]  •  Participantes: [RESPONSÁVEIS]</a:t>
+            <a:r>
+              <a:t>Acompanhamento: atualizar o status conforme a evolução das medidas • Participantes: [RESPONSÁVEIS]</a:t>
             </a:r>
           </a:p>
         </p:txBody>

</xml_diff>

<commit_message>
Ajusta ASO padrão, ações PGR e consolidação GFIP
</commit_message>
<xml_diff>
--- a/Modelo_Devolutiva_SST_Fortneer.pptx
+++ b/Modelo_Devolutiva_SST_Fortneer.pptx
@@ -13529,20 +13529,8 @@
           <a:bodyPr xmlns:a="http://schemas.openxmlformats.org/drawingml/2006/main" anchor="ctr"/>
           <a:lstStyle xmlns:a="http://schemas.openxmlformats.org/drawingml/2006/main"/>
           <a:p xmlns:a="http://schemas.openxmlformats.org/drawingml/2006/main">
-            <a:pPr algn="l">
-              <a:defRPr sz="2475" b="1">
-                <a:solidFill>
-                  <a:srgbClr val="074B32"/>
-                </a:solidFill>
-              </a:defRPr>
-            </a:pPr>
-            <a:r>
-              <a:rPr sz="2475" b="1">
-                <a:solidFill>
-                  <a:srgbClr val="074B32"/>
-                </a:solidFill>
-              </a:rPr>
-              <a:t>Os riscos prioritários concentram as primeiras ações</a:t>
+            <a:r>
+              <a:t>Riscos e condições que concentram as primeiras ações</a:t>
             </a:r>
           </a:p>
         </p:txBody>
@@ -13865,20 +13853,8 @@
           <a:bodyPr xmlns:a="http://schemas.openxmlformats.org/drawingml/2006/main" anchor="ctr"/>
           <a:lstStyle xmlns:a="http://schemas.openxmlformats.org/drawingml/2006/main"/>
           <a:p xmlns:a="http://schemas.openxmlformats.org/drawingml/2006/main">
-            <a:pPr algn="l">
-              <a:defRPr sz="1275" b="1">
-                <a:solidFill>
-                  <a:srgbClr val="FFFFFF"/>
-                </a:solidFill>
-              </a:defRPr>
-            </a:pPr>
-            <a:r>
-              <a:rPr sz="1275" b="1">
-                <a:solidFill>
-                  <a:srgbClr val="FFFFFF"/>
-                </a:solidFill>
-              </a:rPr>
-              <a:t>FÍSICO</a:t>
+            <a:r>
+              <a:t>ITEM 1</a:t>
             </a:r>
           </a:p>
         </p:txBody>
@@ -14083,20 +14059,8 @@
           <a:bodyPr xmlns:a="http://schemas.openxmlformats.org/drawingml/2006/main" anchor="ctr"/>
           <a:lstStyle xmlns:a="http://schemas.openxmlformats.org/drawingml/2006/main"/>
           <a:p xmlns:a="http://schemas.openxmlformats.org/drawingml/2006/main">
-            <a:pPr algn="l">
-              <a:defRPr sz="1275" b="1">
-                <a:solidFill>
-                  <a:srgbClr val="FFFFFF"/>
-                </a:solidFill>
-              </a:defRPr>
-            </a:pPr>
-            <a:r>
-              <a:rPr sz="1275" b="1">
-                <a:solidFill>
-                  <a:srgbClr val="FFFFFF"/>
-                </a:solidFill>
-              </a:rPr>
-              <a:t>QUÍMICO</a:t>
+            <a:r>
+              <a:t>ITEM 2</a:t>
             </a:r>
           </a:p>
         </p:txBody>
@@ -14301,20 +14265,8 @@
           <a:bodyPr xmlns:a="http://schemas.openxmlformats.org/drawingml/2006/main" anchor="ctr"/>
           <a:lstStyle xmlns:a="http://schemas.openxmlformats.org/drawingml/2006/main"/>
           <a:p xmlns:a="http://schemas.openxmlformats.org/drawingml/2006/main">
-            <a:pPr algn="l">
-              <a:defRPr sz="1275" b="1">
-                <a:solidFill>
-                  <a:srgbClr val="FFFFFF"/>
-                </a:solidFill>
-              </a:defRPr>
-            </a:pPr>
-            <a:r>
-              <a:rPr sz="1275" b="1">
-                <a:solidFill>
-                  <a:srgbClr val="FFFFFF"/>
-                </a:solidFill>
-              </a:rPr>
-              <a:t>BIOLÓGICO</a:t>
+            <a:r>
+              <a:t>ITEM 3</a:t>
             </a:r>
           </a:p>
         </p:txBody>
@@ -14519,20 +14471,8 @@
           <a:bodyPr xmlns:a="http://schemas.openxmlformats.org/drawingml/2006/main" anchor="ctr"/>
           <a:lstStyle xmlns:a="http://schemas.openxmlformats.org/drawingml/2006/main"/>
           <a:p xmlns:a="http://schemas.openxmlformats.org/drawingml/2006/main">
-            <a:pPr algn="l">
-              <a:defRPr sz="1275" b="1">
-                <a:solidFill>
-                  <a:srgbClr val="FFFFFF"/>
-                </a:solidFill>
-              </a:defRPr>
-            </a:pPr>
-            <a:r>
-              <a:rPr sz="1275" b="1">
-                <a:solidFill>
-                  <a:srgbClr val="FFFFFF"/>
-                </a:solidFill>
-              </a:rPr>
-              <a:t>ERGONÔMICO</a:t>
+            <a:r>
+              <a:t>ITEM 4</a:t>
             </a:r>
           </a:p>
         </p:txBody>
@@ -14737,20 +14677,8 @@
           <a:bodyPr xmlns:a="http://schemas.openxmlformats.org/drawingml/2006/main" anchor="ctr"/>
           <a:lstStyle xmlns:a="http://schemas.openxmlformats.org/drawingml/2006/main"/>
           <a:p xmlns:a="http://schemas.openxmlformats.org/drawingml/2006/main">
-            <a:pPr algn="l">
-              <a:defRPr sz="1275" b="1">
-                <a:solidFill>
-                  <a:srgbClr val="FFFFFF"/>
-                </a:solidFill>
-              </a:defRPr>
-            </a:pPr>
-            <a:r>
-              <a:rPr sz="1275" b="1">
-                <a:solidFill>
-                  <a:srgbClr val="FFFFFF"/>
-                </a:solidFill>
-              </a:rPr>
-              <a:t>ACIDENTE</a:t>
+            <a:r>
+              <a:t>ITEM 5</a:t>
             </a:r>
           </a:p>
         </p:txBody>
@@ -14887,20 +14815,8 @@
           <a:bodyPr xmlns:a="http://schemas.openxmlformats.org/drawingml/2006/main" anchor="ctr"/>
           <a:lstStyle xmlns:a="http://schemas.openxmlformats.org/drawingml/2006/main"/>
           <a:p xmlns:a="http://schemas.openxmlformats.org/drawingml/2006/main">
-            <a:pPr algn="l">
-              <a:defRPr sz="1050" b="0">
-                <a:solidFill>
-                  <a:srgbClr val="60776B"/>
-                </a:solidFill>
-              </a:defRPr>
-            </a:pPr>
-            <a:r>
-              <a:rPr sz="1050" b="0">
-                <a:solidFill>
-                  <a:srgbClr val="60776B"/>
-                </a:solidFill>
-              </a:rPr>
-              <a:t>Classificação e medidas devem reproduzir as conclusões dos documentos técnicos vigentes.</a:t>
+            <a:r>
+              <a:t>As ações são apresentadas por prioridade e escopo, sem vinculação automática a grupos de risco.</a:t>
             </a:r>
           </a:p>
         </p:txBody>

</xml_diff>

<commit_message>
Remove prazos e datas lasdfasdfsadfsadfimite das ações do PGR
</commit_message>
<xml_diff>
--- a/Modelo_Devolutiva_SST_Fortneer.pptx
+++ b/Modelo_Devolutiva_SST_Fortneer.pptx
@@ -8883,7 +8883,7 @@
                   <a:srgbClr val="FFFFFF"/>
                 </a:solidFill>
               </a:rPr>
-              <a:t>Registrar evidências e acompanhar prazos</a:t>
+              <a:t>Registrar evidências e acompanhar a evolução das medidas</a:t>
             </a:r>
           </a:p>
         </p:txBody>
@@ -10168,7 +10168,7 @@
                   <a:srgbClr val="16372A"/>
                 </a:solidFill>
               </a:rPr>
-              <a:t>Responsáveis, prazos e evolução das medidas</a:t>
+              <a:t>Responsáveis, evidências e evolução das medidas</a:t>
             </a:r>
           </a:p>
         </p:txBody>
@@ -12501,20 +12501,8 @@
           <a:bodyPr xmlns:a="http://schemas.openxmlformats.org/drawingml/2006/main" anchor="ctr"/>
           <a:lstStyle xmlns:a="http://schemas.openxmlformats.org/drawingml/2006/main"/>
           <a:p xmlns:a="http://schemas.openxmlformats.org/drawingml/2006/main">
-            <a:pPr algn="r">
-              <a:defRPr sz="1350" b="0">
-                <a:solidFill>
-                  <a:srgbClr val="60776B"/>
-                </a:solidFill>
-              </a:defRPr>
-            </a:pPr>
-            <a:r>
-              <a:rPr sz="1350" b="0">
-                <a:solidFill>
-                  <a:srgbClr val="60776B"/>
-                </a:solidFill>
-              </a:rPr>
-              <a:t>[00% dentro do prazo]</a:t>
+            <a:r>
+              <a:t>[Situação dos exames ocupacionais]</a:t>
             </a:r>
           </a:p>
         </p:txBody>
@@ -13245,7 +13233,7 @@
                   <a:srgbClr val="FFFFFF"/>
                 </a:solidFill>
               </a:rPr>
-              <a:t>Riscos e controles</a:t>
+              <a:t>Ações e controles</a:t>
             </a:r>
           </a:p>
         </p:txBody>
@@ -13295,7 +13283,7 @@
                   <a:srgbClr val="DDF3E5"/>
                 </a:solidFill>
               </a:rPr>
-              <a:t>O que foi identificado e como reduzir a exposição.</a:t>
+              <a:t>Medidas priorizadas e acompanhamento da execução.</a:t>
             </a:r>
           </a:p>
         </p:txBody>
@@ -13530,7 +13518,7 @@
           <a:lstStyle xmlns:a="http://schemas.openxmlformats.org/drawingml/2006/main"/>
           <a:p xmlns:a="http://schemas.openxmlformats.org/drawingml/2006/main">
             <a:r>
-              <a:t>Riscos e condições que concentram as primeiras ações</a:t>
+              <a:t>Ações prioritárias do PGR</a:t>
             </a:r>
           </a:p>
         </p:txBody>
@@ -13854,7 +13842,7 @@
           <a:lstStyle xmlns:a="http://schemas.openxmlformats.org/drawingml/2006/main"/>
           <a:p xmlns:a="http://schemas.openxmlformats.org/drawingml/2006/main">
             <a:r>
-              <a:t>ITEM 1</a:t>
+              <a:t>AÇÃO 1</a:t>
             </a:r>
           </a:p>
         </p:txBody>
@@ -13904,7 +13892,7 @@
                   <a:srgbClr val="16372A"/>
                 </a:solidFill>
               </a:rPr>
-              <a:t>[Ex.: ruído]</a:t>
+              <a:t>[Ação recomendada]</a:t>
             </a:r>
           </a:p>
         </p:txBody>
@@ -13954,7 +13942,7 @@
                   <a:srgbClr val="60776B"/>
                 </a:solidFill>
               </a:rPr>
-              <a:t>[Setores/funções]</a:t>
+              <a:t>[Setor/Cargo afetado]</a:t>
             </a:r>
           </a:p>
         </p:txBody>
@@ -14060,7 +14048,7 @@
           <a:lstStyle xmlns:a="http://schemas.openxmlformats.org/drawingml/2006/main"/>
           <a:p xmlns:a="http://schemas.openxmlformats.org/drawingml/2006/main">
             <a:r>
-              <a:t>ITEM 2</a:t>
+              <a:t>AÇÃO 2</a:t>
             </a:r>
           </a:p>
         </p:txBody>
@@ -14110,7 +14098,7 @@
                   <a:srgbClr val="16372A"/>
                 </a:solidFill>
               </a:rPr>
-              <a:t>[Agente]</a:t>
+              <a:t>[Ação recomendada]</a:t>
             </a:r>
           </a:p>
         </p:txBody>
@@ -14160,7 +14148,7 @@
                   <a:srgbClr val="60776B"/>
                 </a:solidFill>
               </a:rPr>
-              <a:t>[Setores/funções]</a:t>
+              <a:t>[Setor/Cargo afetado]</a:t>
             </a:r>
           </a:p>
         </p:txBody>
@@ -14266,7 +14254,7 @@
           <a:lstStyle xmlns:a="http://schemas.openxmlformats.org/drawingml/2006/main"/>
           <a:p xmlns:a="http://schemas.openxmlformats.org/drawingml/2006/main">
             <a:r>
-              <a:t>ITEM 3</a:t>
+              <a:t>AÇÃO 3</a:t>
             </a:r>
           </a:p>
         </p:txBody>
@@ -14316,7 +14304,7 @@
                   <a:srgbClr val="16372A"/>
                 </a:solidFill>
               </a:rPr>
-              <a:t>[Agente]</a:t>
+              <a:t>[Ação recomendada]</a:t>
             </a:r>
           </a:p>
         </p:txBody>
@@ -14366,7 +14354,7 @@
                   <a:srgbClr val="60776B"/>
                 </a:solidFill>
               </a:rPr>
-              <a:t>[Setores/funções]</a:t>
+              <a:t>[Setor/Cargo afetado]</a:t>
             </a:r>
           </a:p>
         </p:txBody>
@@ -14472,7 +14460,7 @@
           <a:lstStyle xmlns:a="http://schemas.openxmlformats.org/drawingml/2006/main"/>
           <a:p xmlns:a="http://schemas.openxmlformats.org/drawingml/2006/main">
             <a:r>
-              <a:t>ITEM 4</a:t>
+              <a:t>AÇÃO 4</a:t>
             </a:r>
           </a:p>
         </p:txBody>
@@ -14522,7 +14510,7 @@
                   <a:srgbClr val="16372A"/>
                 </a:solidFill>
               </a:rPr>
-              <a:t>[Condição]</a:t>
+              <a:t>[Ação recomendada]</a:t>
             </a:r>
           </a:p>
         </p:txBody>
@@ -14572,7 +14560,7 @@
                   <a:srgbClr val="60776B"/>
                 </a:solidFill>
               </a:rPr>
-              <a:t>[Setores/funções]</a:t>
+              <a:t>[Setor/Cargo afetado]</a:t>
             </a:r>
           </a:p>
         </p:txBody>
@@ -14678,7 +14666,7 @@
           <a:lstStyle xmlns:a="http://schemas.openxmlformats.org/drawingml/2006/main"/>
           <a:p xmlns:a="http://schemas.openxmlformats.org/drawingml/2006/main">
             <a:r>
-              <a:t>ITEM 5</a:t>
+              <a:t>AÇÃO 5</a:t>
             </a:r>
           </a:p>
         </p:txBody>
@@ -14728,7 +14716,7 @@
                   <a:srgbClr val="16372A"/>
                 </a:solidFill>
               </a:rPr>
-              <a:t>[Condição]</a:t>
+              <a:t>[Ação recomendada]</a:t>
             </a:r>
           </a:p>
         </p:txBody>
@@ -14778,7 +14766,7 @@
                   <a:srgbClr val="60776B"/>
                 </a:solidFill>
               </a:rPr>
-              <a:t>[Setores/funções]</a:t>
+              <a:t>[Setor/Cargo afetado]</a:t>
             </a:r>
           </a:p>
         </p:txBody>
@@ -14816,7 +14804,7 @@
           <a:lstStyle xmlns:a="http://schemas.openxmlformats.org/drawingml/2006/main"/>
           <a:p xmlns:a="http://schemas.openxmlformats.org/drawingml/2006/main">
             <a:r>
-              <a:t>As ações são apresentadas por prioridade e escopo, sem vinculação automática a grupos de risco.</a:t>
+              <a:t>As ações são apresentadas diretamente por prioridade e escopo.</a:t>
             </a:r>
           </a:p>
         </p:txBody>

</xml_diff>